<commit_message>
Restyle presentation with HIMPEL's actual brand palette
Swap the generic teal palette for colors pulled from the real himpel.com storefront: deep brand green for solutions/success elements, a warm terracotta for pain points, black headline text, and a sand tint echoing the wood/cream bathroom photography. Add a small HIMPEL wordmark as a consistent brand motif across all three slides.

Co-Authored-By: Claude Sonnet 5 <noreply@anthropic.com>
Claude-Session: https://claude.ai/code/session_01EmyHLFk5e1jt7GDTucAEBt
</commit_message>
<xml_diff>
--- a/assignments/entrepreneur-presentation-himpel/HIMPEL_entrepreneur_presentation.pptx
+++ b/assignments/entrepreneur-presentation-himpel/HIMPEL_entrepreneur_presentation.pptx
@@ -1075,7 +1075,7 @@
         <p:spPr>
           <a:xfrm>
             <a:off x="457200" y="365760"/>
-            <a:ext cx="7315200" cy="320040"/>
+            <a:ext cx="2743200" cy="365760"/>
           </a:xfrm>
           <a:prstGeom prst="rect">
             <a:avLst/>
@@ -1084,24 +1084,24 @@
           <a:ln/>
         </p:spPr>
         <p:txBody>
-          <a:bodyPr wrap="square" rtlCol="0" anchor="ctr"/>
+          <a:bodyPr wrap="square" lIns="0" tIns="0" rIns="0" bIns="0" rtlCol="0" anchor="ctr"/>
           <a:lstStyle/>
           <a:p>
             <a:pPr indent="0" marL="0">
               <a:buNone/>
             </a:pPr>
             <a:r>
-              <a:rPr lang="en-US" sz="1300" b="1" spc="200" kern="0" dirty="0">
-                <a:solidFill>
-                  <a:srgbClr val="028090"/>
+              <a:rPr lang="en-US" sz="1800" b="1" spc="100" kern="0" dirty="0">
+                <a:solidFill>
+                  <a:srgbClr val="1C4A34"/>
                 </a:solidFill>
                 <a:latin typeface="Calibri" pitchFamily="34" charset="0"/>
                 <a:ea typeface="Calibri" pitchFamily="34" charset="-122"/>
                 <a:cs typeface="Calibri" pitchFamily="34" charset="-120"/>
               </a:rPr>
-              <a:t>KIM JUNG-HWAN  ·  FOUNDER, HIMPEL</a:t>
-            </a:r>
-            <a:endParaRPr lang="en-US" sz="1300" dirty="0"/>
+              <a:t>HIMPEL</a:t>
+            </a:r>
+            <a:endParaRPr lang="en-US" sz="1800" dirty="0"/>
           </a:p>
         </p:txBody>
       </p:sp>
@@ -1113,7 +1113,46 @@
         </p:nvSpPr>
         <p:spPr>
           <a:xfrm>
-            <a:off x="457200" y="777240"/>
+            <a:off x="457200" y="713232"/>
+            <a:ext cx="5486400" cy="274320"/>
+          </a:xfrm>
+          <a:prstGeom prst="rect">
+            <a:avLst/>
+          </a:prstGeom>
+          <a:noFill/>
+          <a:ln/>
+        </p:spPr>
+        <p:txBody>
+          <a:bodyPr wrap="square" rtlCol="0" anchor="ctr"/>
+          <a:lstStyle/>
+          <a:p>
+            <a:pPr indent="0" marL="0">
+              <a:buNone/>
+            </a:pPr>
+            <a:r>
+              <a:rPr lang="en-US" sz="1200" b="1" spc="150" kern="0" dirty="0">
+                <a:solidFill>
+                  <a:srgbClr val="6B6B6B"/>
+                </a:solidFill>
+                <a:latin typeface="Calibri" pitchFamily="34" charset="0"/>
+                <a:ea typeface="Calibri" pitchFamily="34" charset="-122"/>
+                <a:cs typeface="Calibri" pitchFamily="34" charset="-120"/>
+              </a:rPr>
+              <a:t>KIM JUNG-HWAN  ·  FOUNDER</a:t>
+            </a:r>
+            <a:endParaRPr lang="en-US" sz="1200" dirty="0"/>
+          </a:p>
+        </p:txBody>
+      </p:sp>
+      <p:sp>
+        <p:nvSpPr>
+          <p:cNvPr id="4" name="Text 2"/>
+          <p:cNvSpPr/>
+          <p:nvPr/>
+        </p:nvSpPr>
+        <p:spPr>
+          <a:xfrm>
+            <a:off x="457200" y="1051560"/>
             <a:ext cx="11247120" cy="1737360"/>
           </a:xfrm>
           <a:prstGeom prst="rect">
@@ -1135,7 +1174,7 @@
             <a:r>
               <a:rPr lang="en-US" sz="3400" b="1" dirty="0">
                 <a:solidFill>
-                  <a:srgbClr val="13343B"/>
+                  <a:srgbClr val="1A1A1A"/>
                 </a:solidFill>
                 <a:latin typeface="Cambria" pitchFamily="34" charset="0"/>
                 <a:ea typeface="Cambria" pitchFamily="34" charset="-122"/>
@@ -1155,7 +1194,7 @@
             <a:r>
               <a:rPr lang="en-US" sz="3400" b="1" dirty="0">
                 <a:solidFill>
-                  <a:srgbClr val="028090"/>
+                  <a:srgbClr val="1C4A34"/>
                 </a:solidFill>
                 <a:latin typeface="Cambria" pitchFamily="34" charset="0"/>
                 <a:ea typeface="Cambria" pitchFamily="34" charset="-122"/>
@@ -1169,13 +1208,13 @@
       </p:sp>
       <p:sp>
         <p:nvSpPr>
-          <p:cNvPr id="4" name="Shape 2"/>
-          <p:cNvSpPr/>
-          <p:nvPr/>
-        </p:nvSpPr>
-        <p:spPr>
-          <a:xfrm>
-            <a:off x="457200" y="2788920"/>
+          <p:cNvPr id="5" name="Shape 3"/>
+          <p:cNvSpPr/>
+          <p:nvPr/>
+        </p:nvSpPr>
+        <p:spPr>
+          <a:xfrm>
+            <a:off x="457200" y="2926080"/>
             <a:ext cx="2468880" cy="1874520"/>
           </a:xfrm>
           <a:prstGeom prst="roundRect">
@@ -1184,14 +1223,14 @@
             </a:avLst>
           </a:prstGeom>
           <a:solidFill>
-            <a:srgbClr val="E6F4F1"/>
+            <a:srgbClr val="F1ECE3"/>
           </a:solidFill>
           <a:ln/>
         </p:spPr>
       </p:sp>
       <p:pic>
         <p:nvPicPr>
-          <p:cNvPr id="5" name="Image 0" descr="icon_wind.png">    </p:cNvPr>
+          <p:cNvPr id="6" name="Image 0" descr="icon_wind.png">    </p:cNvPr>
           <p:cNvPicPr>
             <a:picLocks noChangeAspect="1"/>
           </p:cNvPicPr>
@@ -1205,7 +1244,7 @@
         </p:blipFill>
         <p:spPr>
           <a:xfrm>
-            <a:off x="1417320" y="3108960"/>
+            <a:off x="1417320" y="3246120"/>
             <a:ext cx="548640" cy="548640"/>
           </a:xfrm>
           <a:prstGeom prst="rect">
@@ -1215,13 +1254,13 @@
       </p:pic>
       <p:sp>
         <p:nvSpPr>
-          <p:cNvPr id="6" name="Text 3"/>
-          <p:cNvSpPr/>
-          <p:nvPr/>
-        </p:nvSpPr>
-        <p:spPr>
-          <a:xfrm>
-            <a:off x="457200" y="3840480"/>
+          <p:cNvPr id="7" name="Text 4"/>
+          <p:cNvSpPr/>
+          <p:nvPr/>
+        </p:nvSpPr>
+        <p:spPr>
+          <a:xfrm>
+            <a:off x="457200" y="3977640"/>
             <a:ext cx="2468880" cy="640080"/>
           </a:xfrm>
           <a:prstGeom prst="rect">
@@ -1240,7 +1279,7 @@
             <a:r>
               <a:rPr lang="en-US" sz="1400" b="1" dirty="0">
                 <a:solidFill>
-                  <a:srgbClr val="13343B"/>
+                  <a:srgbClr val="1A1A1A"/>
                 </a:solidFill>
                 <a:latin typeface="Calibri" pitchFamily="34" charset="0"/>
                 <a:ea typeface="Calibri" pitchFamily="34" charset="-122"/>
@@ -1254,13 +1293,13 @@
       </p:sp>
       <p:sp>
         <p:nvSpPr>
-          <p:cNvPr id="7" name="Shape 4"/>
-          <p:cNvSpPr/>
-          <p:nvPr/>
-        </p:nvSpPr>
-        <p:spPr>
-          <a:xfrm>
-            <a:off x="3200400" y="2788920"/>
+          <p:cNvPr id="8" name="Shape 5"/>
+          <p:cNvSpPr/>
+          <p:nvPr/>
+        </p:nvSpPr>
+        <p:spPr>
+          <a:xfrm>
+            <a:off x="3200400" y="2926080"/>
             <a:ext cx="2468880" cy="1874520"/>
           </a:xfrm>
           <a:prstGeom prst="roundRect">
@@ -1269,14 +1308,14 @@
             </a:avLst>
           </a:prstGeom>
           <a:solidFill>
-            <a:srgbClr val="E6F4F1"/>
+            <a:srgbClr val="F1ECE3"/>
           </a:solidFill>
           <a:ln/>
         </p:spPr>
       </p:sp>
       <p:pic>
         <p:nvPicPr>
-          <p:cNvPr id="8" name="Image 1" descr="icon_volume.png">    </p:cNvPr>
+          <p:cNvPr id="9" name="Image 1" descr="icon_volume.png">    </p:cNvPr>
           <p:cNvPicPr>
             <a:picLocks noChangeAspect="1"/>
           </p:cNvPicPr>
@@ -1290,7 +1329,7 @@
         </p:blipFill>
         <p:spPr>
           <a:xfrm>
-            <a:off x="4160520" y="3108960"/>
+            <a:off x="4160520" y="3246120"/>
             <a:ext cx="548640" cy="548640"/>
           </a:xfrm>
           <a:prstGeom prst="rect">
@@ -1300,13 +1339,13 @@
       </p:pic>
       <p:sp>
         <p:nvSpPr>
-          <p:cNvPr id="9" name="Text 5"/>
-          <p:cNvSpPr/>
-          <p:nvPr/>
-        </p:nvSpPr>
-        <p:spPr>
-          <a:xfrm>
-            <a:off x="3200400" y="3840480"/>
+          <p:cNvPr id="10" name="Text 6"/>
+          <p:cNvSpPr/>
+          <p:nvPr/>
+        </p:nvSpPr>
+        <p:spPr>
+          <a:xfrm>
+            <a:off x="3200400" y="3977640"/>
             <a:ext cx="2468880" cy="640080"/>
           </a:xfrm>
           <a:prstGeom prst="rect">
@@ -1325,7 +1364,7 @@
             <a:r>
               <a:rPr lang="en-US" sz="1400" b="1" dirty="0">
                 <a:solidFill>
-                  <a:srgbClr val="13343B"/>
+                  <a:srgbClr val="1A1A1A"/>
                 </a:solidFill>
                 <a:latin typeface="Calibri" pitchFamily="34" charset="0"/>
                 <a:ea typeface="Calibri" pitchFamily="34" charset="-122"/>
@@ -1339,13 +1378,13 @@
       </p:sp>
       <p:sp>
         <p:nvSpPr>
-          <p:cNvPr id="10" name="Shape 6"/>
-          <p:cNvSpPr/>
-          <p:nvPr/>
-        </p:nvSpPr>
-        <p:spPr>
-          <a:xfrm>
-            <a:off x="5943600" y="2788920"/>
+          <p:cNvPr id="11" name="Shape 7"/>
+          <p:cNvSpPr/>
+          <p:nvPr/>
+        </p:nvSpPr>
+        <p:spPr>
+          <a:xfrm>
+            <a:off x="5943600" y="2926080"/>
             <a:ext cx="2468880" cy="1874520"/>
           </a:xfrm>
           <a:prstGeom prst="roundRect">
@@ -1354,14 +1393,14 @@
             </a:avLst>
           </a:prstGeom>
           <a:solidFill>
-            <a:srgbClr val="E6F4F1"/>
+            <a:srgbClr val="F1ECE3"/>
           </a:solidFill>
           <a:ln/>
         </p:spPr>
       </p:sp>
       <p:pic>
         <p:nvPicPr>
-          <p:cNvPr id="11" name="Image 2" descr="icon_fog.png">    </p:cNvPr>
+          <p:cNvPr id="12" name="Image 2" descr="icon_fog.png">    </p:cNvPr>
           <p:cNvPicPr>
             <a:picLocks noChangeAspect="1"/>
           </p:cNvPicPr>
@@ -1375,7 +1414,7 @@
         </p:blipFill>
         <p:spPr>
           <a:xfrm>
-            <a:off x="6903720" y="3108960"/>
+            <a:off x="6903720" y="3246120"/>
             <a:ext cx="548640" cy="548640"/>
           </a:xfrm>
           <a:prstGeom prst="rect">
@@ -1385,13 +1424,13 @@
       </p:pic>
       <p:sp>
         <p:nvSpPr>
-          <p:cNvPr id="12" name="Text 7"/>
-          <p:cNvSpPr/>
-          <p:nvPr/>
-        </p:nvSpPr>
-        <p:spPr>
-          <a:xfrm>
-            <a:off x="5943600" y="3840480"/>
+          <p:cNvPr id="13" name="Text 8"/>
+          <p:cNvSpPr/>
+          <p:nvPr/>
+        </p:nvSpPr>
+        <p:spPr>
+          <a:xfrm>
+            <a:off x="5943600" y="3977640"/>
             <a:ext cx="2468880" cy="640080"/>
           </a:xfrm>
           <a:prstGeom prst="rect">
@@ -1410,7 +1449,7 @@
             <a:r>
               <a:rPr lang="en-US" sz="1400" b="1" dirty="0">
                 <a:solidFill>
-                  <a:srgbClr val="13343B"/>
+                  <a:srgbClr val="1A1A1A"/>
                 </a:solidFill>
                 <a:latin typeface="Calibri" pitchFamily="34" charset="0"/>
                 <a:ea typeface="Calibri" pitchFamily="34" charset="-122"/>
@@ -1424,13 +1463,13 @@
       </p:sp>
       <p:sp>
         <p:nvSpPr>
-          <p:cNvPr id="13" name="Shape 8"/>
-          <p:cNvSpPr/>
-          <p:nvPr/>
-        </p:nvSpPr>
-        <p:spPr>
-          <a:xfrm>
-            <a:off x="8686800" y="2788920"/>
+          <p:cNvPr id="14" name="Shape 9"/>
+          <p:cNvSpPr/>
+          <p:nvPr/>
+        </p:nvSpPr>
+        <p:spPr>
+          <a:xfrm>
+            <a:off x="8686800" y="2926080"/>
             <a:ext cx="2468880" cy="1874520"/>
           </a:xfrm>
           <a:prstGeom prst="roundRect">
@@ -1439,14 +1478,14 @@
             </a:avLst>
           </a:prstGeom>
           <a:solidFill>
-            <a:srgbClr val="E6F4F1"/>
+            <a:srgbClr val="F1ECE3"/>
           </a:solidFill>
           <a:ln/>
         </p:spPr>
       </p:sp>
       <p:pic>
         <p:nvPicPr>
-          <p:cNvPr id="14" name="Image 3" descr="icon_droplets.png">    </p:cNvPr>
+          <p:cNvPr id="15" name="Image 3" descr="icon_droplets.png">    </p:cNvPr>
           <p:cNvPicPr>
             <a:picLocks noChangeAspect="1"/>
           </p:cNvPicPr>
@@ -1460,7 +1499,7 @@
         </p:blipFill>
         <p:spPr>
           <a:xfrm>
-            <a:off x="9646920" y="3108960"/>
+            <a:off x="9646920" y="3246120"/>
             <a:ext cx="548640" cy="548640"/>
           </a:xfrm>
           <a:prstGeom prst="rect">
@@ -1470,13 +1509,13 @@
       </p:pic>
       <p:sp>
         <p:nvSpPr>
-          <p:cNvPr id="15" name="Text 9"/>
-          <p:cNvSpPr/>
-          <p:nvPr/>
-        </p:nvSpPr>
-        <p:spPr>
-          <a:xfrm>
-            <a:off x="8686800" y="3840480"/>
+          <p:cNvPr id="16" name="Text 10"/>
+          <p:cNvSpPr/>
+          <p:nvPr/>
+        </p:nvSpPr>
+        <p:spPr>
+          <a:xfrm>
+            <a:off x="8686800" y="3977640"/>
             <a:ext cx="2468880" cy="640080"/>
           </a:xfrm>
           <a:prstGeom prst="rect">
@@ -1495,7 +1534,7 @@
             <a:r>
               <a:rPr lang="en-US" sz="1400" b="1" dirty="0">
                 <a:solidFill>
-                  <a:srgbClr val="13343B"/>
+                  <a:srgbClr val="1A1A1A"/>
                 </a:solidFill>
                 <a:latin typeface="Calibri" pitchFamily="34" charset="0"/>
                 <a:ea typeface="Calibri" pitchFamily="34" charset="-122"/>
@@ -1509,13 +1548,13 @@
       </p:sp>
       <p:sp>
         <p:nvSpPr>
-          <p:cNvPr id="16" name="Text 10"/>
-          <p:cNvSpPr/>
-          <p:nvPr/>
-        </p:nvSpPr>
-        <p:spPr>
-          <a:xfrm>
-            <a:off x="457200" y="5074920"/>
+          <p:cNvPr id="17" name="Text 11"/>
+          <p:cNvSpPr/>
+          <p:nvPr/>
+        </p:nvSpPr>
+        <p:spPr>
+          <a:xfrm>
+            <a:off x="457200" y="5212080"/>
             <a:ext cx="11247120" cy="548640"/>
           </a:xfrm>
           <a:prstGeom prst="rect">
@@ -1534,7 +1573,7 @@
             <a:r>
               <a:rPr lang="en-US" sz="1500" i="1" dirty="0">
                 <a:solidFill>
-                  <a:srgbClr val="5B6B6E"/>
+                  <a:srgbClr val="6B6B6B"/>
                 </a:solidFill>
                 <a:latin typeface="Calibri" pitchFamily="34" charset="0"/>
                 <a:ea typeface="Calibri" pitchFamily="34" charset="-122"/>
@@ -1586,8 +1625,47 @@
         </p:nvSpPr>
         <p:spPr>
           <a:xfrm>
+            <a:off x="10195560" y="384048"/>
+            <a:ext cx="1554480" cy="320040"/>
+          </a:xfrm>
+          <a:prstGeom prst="rect">
+            <a:avLst/>
+          </a:prstGeom>
+          <a:noFill/>
+          <a:ln/>
+        </p:spPr>
+        <p:txBody>
+          <a:bodyPr wrap="square" lIns="0" tIns="0" rIns="0" bIns="0" rtlCol="0" anchor="ctr"/>
+          <a:lstStyle/>
+          <a:p>
+            <a:pPr algn="r" indent="0" marL="0">
+              <a:buNone/>
+            </a:pPr>
+            <a:r>
+              <a:rPr lang="en-US" sz="1600" b="1" spc="100" kern="0" dirty="0">
+                <a:solidFill>
+                  <a:srgbClr val="1C4A34"/>
+                </a:solidFill>
+                <a:latin typeface="Calibri" pitchFamily="34" charset="0"/>
+                <a:ea typeface="Calibri" pitchFamily="34" charset="-122"/>
+                <a:cs typeface="Calibri" pitchFamily="34" charset="-120"/>
+              </a:rPr>
+              <a:t>HIMPEL</a:t>
+            </a:r>
+            <a:endParaRPr lang="en-US" sz="1600" dirty="0"/>
+          </a:p>
+        </p:txBody>
+      </p:sp>
+      <p:sp>
+        <p:nvSpPr>
+          <p:cNvPr id="3" name="Text 1"/>
+          <p:cNvSpPr/>
+          <p:nvPr/>
+        </p:nvSpPr>
+        <p:spPr>
+          <a:xfrm>
             <a:off x="457200" y="365760"/>
-            <a:ext cx="11247120" cy="640080"/>
+            <a:ext cx="9509760" cy="640080"/>
           </a:xfrm>
           <a:prstGeom prst="rect">
             <a:avLst/>
@@ -1605,7 +1683,7 @@
             <a:r>
               <a:rPr lang="en-US" sz="3200" b="1" dirty="0">
                 <a:solidFill>
-                  <a:srgbClr val="13343B"/>
+                  <a:srgbClr val="1A1A1A"/>
                 </a:solidFill>
                 <a:latin typeface="Cambria" pitchFamily="34" charset="0"/>
                 <a:ea typeface="Cambria" pitchFamily="34" charset="-122"/>
@@ -1619,7 +1697,7 @@
       </p:sp>
       <p:sp>
         <p:nvSpPr>
-          <p:cNvPr id="3" name="Shape 1"/>
+          <p:cNvPr id="4" name="Shape 2"/>
           <p:cNvSpPr/>
           <p:nvPr/>
         </p:nvSpPr>
@@ -1632,14 +1710,14 @@
             <a:avLst/>
           </a:prstGeom>
           <a:solidFill>
-            <a:srgbClr val="028090"/>
+            <a:srgbClr val="1C4A34"/>
           </a:solidFill>
           <a:ln/>
         </p:spPr>
       </p:sp>
       <p:sp>
         <p:nvSpPr>
-          <p:cNvPr id="4" name="Text 2"/>
+          <p:cNvPr id="5" name="Text 3"/>
           <p:cNvSpPr/>
           <p:nvPr/>
         </p:nvSpPr>
@@ -1678,7 +1756,7 @@
       </p:sp>
       <p:sp>
         <p:nvSpPr>
-          <p:cNvPr id="5" name="Text 3"/>
+          <p:cNvPr id="6" name="Text 4"/>
           <p:cNvSpPr/>
           <p:nvPr/>
         </p:nvSpPr>
@@ -1703,7 +1781,7 @@
             <a:r>
               <a:rPr lang="en-US" sz="1450" dirty="0">
                 <a:solidFill>
-                  <a:srgbClr val="13343B"/>
+                  <a:srgbClr val="1A1A1A"/>
                 </a:solidFill>
                 <a:latin typeface="Calibri" pitchFamily="34" charset="0"/>
                 <a:ea typeface="Calibri" pitchFamily="34" charset="-122"/>
@@ -1717,7 +1795,7 @@
       </p:sp>
       <p:sp>
         <p:nvSpPr>
-          <p:cNvPr id="6" name="Shape 4"/>
+          <p:cNvPr id="7" name="Shape 5"/>
           <p:cNvSpPr/>
           <p:nvPr/>
         </p:nvSpPr>
@@ -1730,14 +1808,14 @@
             <a:avLst/>
           </a:prstGeom>
           <a:solidFill>
-            <a:srgbClr val="028090"/>
+            <a:srgbClr val="1C4A34"/>
           </a:solidFill>
           <a:ln/>
         </p:spPr>
       </p:sp>
       <p:sp>
         <p:nvSpPr>
-          <p:cNvPr id="7" name="Text 5"/>
+          <p:cNvPr id="8" name="Text 6"/>
           <p:cNvSpPr/>
           <p:nvPr/>
         </p:nvSpPr>
@@ -1776,7 +1854,7 @@
       </p:sp>
       <p:sp>
         <p:nvSpPr>
-          <p:cNvPr id="8" name="Text 6"/>
+          <p:cNvPr id="9" name="Text 7"/>
           <p:cNvSpPr/>
           <p:nvPr/>
         </p:nvSpPr>
@@ -1801,7 +1879,7 @@
             <a:r>
               <a:rPr lang="en-US" sz="1450" dirty="0">
                 <a:solidFill>
-                  <a:srgbClr val="13343B"/>
+                  <a:srgbClr val="1A1A1A"/>
                 </a:solidFill>
                 <a:latin typeface="Calibri" pitchFamily="34" charset="0"/>
                 <a:ea typeface="Calibri" pitchFamily="34" charset="-122"/>
@@ -1815,7 +1893,7 @@
       </p:sp>
       <p:sp>
         <p:nvSpPr>
-          <p:cNvPr id="9" name="Shape 7"/>
+          <p:cNvPr id="10" name="Shape 8"/>
           <p:cNvSpPr/>
           <p:nvPr/>
         </p:nvSpPr>
@@ -1828,14 +1906,14 @@
             <a:avLst/>
           </a:prstGeom>
           <a:solidFill>
-            <a:srgbClr val="028090"/>
+            <a:srgbClr val="1C4A34"/>
           </a:solidFill>
           <a:ln/>
         </p:spPr>
       </p:sp>
       <p:sp>
         <p:nvSpPr>
-          <p:cNvPr id="10" name="Text 8"/>
+          <p:cNvPr id="11" name="Text 9"/>
           <p:cNvSpPr/>
           <p:nvPr/>
         </p:nvSpPr>
@@ -1874,7 +1952,7 @@
       </p:sp>
       <p:sp>
         <p:nvSpPr>
-          <p:cNvPr id="11" name="Text 9"/>
+          <p:cNvPr id="12" name="Text 10"/>
           <p:cNvSpPr/>
           <p:nvPr/>
         </p:nvSpPr>
@@ -1899,7 +1977,7 @@
             <a:r>
               <a:rPr lang="en-US" sz="1450" dirty="0">
                 <a:solidFill>
-                  <a:srgbClr val="13343B"/>
+                  <a:srgbClr val="1A1A1A"/>
                 </a:solidFill>
                 <a:latin typeface="Calibri" pitchFamily="34" charset="0"/>
                 <a:ea typeface="Calibri" pitchFamily="34" charset="-122"/>
@@ -1913,7 +1991,7 @@
       </p:sp>
       <p:sp>
         <p:nvSpPr>
-          <p:cNvPr id="12" name="Shape 10"/>
+          <p:cNvPr id="13" name="Shape 11"/>
           <p:cNvSpPr/>
           <p:nvPr/>
         </p:nvSpPr>
@@ -1928,14 +2006,14 @@
             </a:avLst>
           </a:prstGeom>
           <a:solidFill>
-            <a:srgbClr val="E6F4F1"/>
+            <a:srgbClr val="E8EEEA"/>
           </a:solidFill>
           <a:ln/>
         </p:spPr>
       </p:sp>
       <p:sp>
         <p:nvSpPr>
-          <p:cNvPr id="13" name="Text 11"/>
+          <p:cNvPr id="14" name="Text 12"/>
           <p:cNvSpPr/>
           <p:nvPr/>
         </p:nvSpPr>
@@ -1960,7 +2038,7 @@
             <a:r>
               <a:rPr lang="en-US" sz="6600" b="1" dirty="0">
                 <a:solidFill>
-                  <a:srgbClr val="028090"/>
+                  <a:srgbClr val="1C4A34"/>
                 </a:solidFill>
                 <a:latin typeface="Cambria" pitchFamily="34" charset="0"/>
                 <a:ea typeface="Cambria" pitchFamily="34" charset="-122"/>
@@ -1974,7 +2052,7 @@
       </p:sp>
       <p:sp>
         <p:nvSpPr>
-          <p:cNvPr id="14" name="Text 12"/>
+          <p:cNvPr id="15" name="Text 13"/>
           <p:cNvSpPr/>
           <p:nvPr/>
         </p:nvSpPr>
@@ -1999,7 +2077,7 @@
             <a:r>
               <a:rPr lang="en-US" sz="1400" dirty="0">
                 <a:solidFill>
-                  <a:srgbClr val="5B6B6E"/>
+                  <a:srgbClr val="6B6B6B"/>
                 </a:solidFill>
                 <a:latin typeface="Calibri" pitchFamily="34" charset="0"/>
                 <a:ea typeface="Calibri" pitchFamily="34" charset="-122"/>
@@ -2016,7 +2094,7 @@
             <a:r>
               <a:rPr lang="en-US" sz="1400" dirty="0">
                 <a:solidFill>
-                  <a:srgbClr val="5B6B6E"/>
+                  <a:srgbClr val="6B6B6B"/>
                 </a:solidFill>
                 <a:latin typeface="Calibri" pitchFamily="34" charset="0"/>
                 <a:ea typeface="Calibri" pitchFamily="34" charset="-122"/>
@@ -2030,7 +2108,7 @@
       </p:sp>
       <p:sp>
         <p:nvSpPr>
-          <p:cNvPr id="15" name="Text 13"/>
+          <p:cNvPr id="16" name="Text 14"/>
           <p:cNvSpPr/>
           <p:nvPr/>
         </p:nvSpPr>
@@ -2055,7 +2133,7 @@
             <a:r>
               <a:rPr lang="en-US" sz="1700" b="1" i="1" dirty="0">
                 <a:solidFill>
-                  <a:srgbClr val="13343B"/>
+                  <a:srgbClr val="1A1A1A"/>
                 </a:solidFill>
                 <a:latin typeface="Cambria" pitchFamily="34" charset="0"/>
                 <a:ea typeface="Cambria" pitchFamily="34" charset="-122"/>
@@ -2107,8 +2185,47 @@
         </p:nvSpPr>
         <p:spPr>
           <a:xfrm>
+            <a:off x="10195560" y="384048"/>
+            <a:ext cx="1554480" cy="320040"/>
+          </a:xfrm>
+          <a:prstGeom prst="rect">
+            <a:avLst/>
+          </a:prstGeom>
+          <a:noFill/>
+          <a:ln/>
+        </p:spPr>
+        <p:txBody>
+          <a:bodyPr wrap="square" lIns="0" tIns="0" rIns="0" bIns="0" rtlCol="0" anchor="ctr"/>
+          <a:lstStyle/>
+          <a:p>
+            <a:pPr algn="r" indent="0" marL="0">
+              <a:buNone/>
+            </a:pPr>
+            <a:r>
+              <a:rPr lang="en-US" sz="1600" b="1" spc="100" kern="0" dirty="0">
+                <a:solidFill>
+                  <a:srgbClr val="1C4A34"/>
+                </a:solidFill>
+                <a:latin typeface="Calibri" pitchFamily="34" charset="0"/>
+                <a:ea typeface="Calibri" pitchFamily="34" charset="-122"/>
+                <a:cs typeface="Calibri" pitchFamily="34" charset="-120"/>
+              </a:rPr>
+              <a:t>HIMPEL</a:t>
+            </a:r>
+            <a:endParaRPr lang="en-US" sz="1600" dirty="0"/>
+          </a:p>
+        </p:txBody>
+      </p:sp>
+      <p:sp>
+        <p:nvSpPr>
+          <p:cNvPr id="3" name="Text 1"/>
+          <p:cNvSpPr/>
+          <p:nvPr/>
+        </p:nvSpPr>
+        <p:spPr>
+          <a:xfrm>
             <a:off x="457200" y="365760"/>
-            <a:ext cx="11247120" cy="548640"/>
+            <a:ext cx="9509760" cy="548640"/>
           </a:xfrm>
           <a:prstGeom prst="rect">
             <a:avLst/>
@@ -2126,7 +2243,7 @@
             <a:r>
               <a:rPr lang="en-US" sz="3200" b="1" dirty="0">
                 <a:solidFill>
-                  <a:srgbClr val="13343B"/>
+                  <a:srgbClr val="1A1A1A"/>
                 </a:solidFill>
                 <a:latin typeface="Cambria" pitchFamily="34" charset="0"/>
                 <a:ea typeface="Cambria" pitchFamily="34" charset="-122"/>
@@ -2140,7 +2257,7 @@
       </p:sp>
       <p:sp>
         <p:nvSpPr>
-          <p:cNvPr id="3" name="Text 1"/>
+          <p:cNvPr id="4" name="Text 2"/>
           <p:cNvSpPr/>
           <p:nvPr/>
         </p:nvSpPr>
@@ -2165,7 +2282,7 @@
             <a:r>
               <a:rPr lang="en-US" sz="1500" i="1" dirty="0">
                 <a:solidFill>
-                  <a:srgbClr val="028090"/>
+                  <a:srgbClr val="1C4A34"/>
                 </a:solidFill>
                 <a:latin typeface="Calibri" pitchFamily="34" charset="0"/>
                 <a:ea typeface="Calibri" pitchFamily="34" charset="-122"/>
@@ -2179,7 +2296,7 @@
       </p:sp>
       <p:sp>
         <p:nvSpPr>
-          <p:cNvPr id="4" name="Shape 2"/>
+          <p:cNvPr id="5" name="Shape 3"/>
           <p:cNvSpPr/>
           <p:nvPr/>
         </p:nvSpPr>
@@ -2194,14 +2311,14 @@
             </a:avLst>
           </a:prstGeom>
           <a:solidFill>
-            <a:srgbClr val="FBEAEA"/>
+            <a:srgbClr val="F6ECE9"/>
           </a:solidFill>
           <a:ln/>
         </p:spPr>
       </p:sp>
       <p:sp>
         <p:nvSpPr>
-          <p:cNvPr id="5" name="Text 3"/>
+          <p:cNvPr id="6" name="Text 4"/>
           <p:cNvSpPr/>
           <p:nvPr/>
         </p:nvSpPr>
@@ -2226,7 +2343,7 @@
             <a:r>
               <a:rPr lang="en-US" sz="1800" b="1" dirty="0">
                 <a:solidFill>
-                  <a:srgbClr val="990011"/>
+                  <a:srgbClr val="8C4A3D"/>
                 </a:solidFill>
                 <a:latin typeface="Calibri" pitchFamily="34" charset="0"/>
                 <a:ea typeface="Calibri" pitchFamily="34" charset="-122"/>
@@ -2240,7 +2357,7 @@
       </p:sp>
       <p:pic>
         <p:nvPicPr>
-          <p:cNvPr id="6" name="Image 0" descr="icon_x.png">    </p:cNvPr>
+          <p:cNvPr id="7" name="Image 0" descr="icon_x.png">    </p:cNvPr>
           <p:cNvPicPr>
             <a:picLocks noChangeAspect="1"/>
           </p:cNvPicPr>
@@ -2264,7 +2381,7 @@
       </p:pic>
       <p:sp>
         <p:nvSpPr>
-          <p:cNvPr id="7" name="Text 4"/>
+          <p:cNvPr id="8" name="Text 5"/>
           <p:cNvSpPr/>
           <p:nvPr/>
         </p:nvSpPr>
@@ -2289,7 +2406,7 @@
             <a:r>
               <a:rPr lang="en-US" sz="1450" dirty="0">
                 <a:solidFill>
-                  <a:srgbClr val="13343B"/>
+                  <a:srgbClr val="1A1A1A"/>
                 </a:solidFill>
                 <a:latin typeface="Calibri" pitchFamily="34" charset="0"/>
                 <a:ea typeface="Calibri" pitchFamily="34" charset="-122"/>
@@ -2303,7 +2420,7 @@
       </p:sp>
       <p:pic>
         <p:nvPicPr>
-          <p:cNvPr id="8" name="Image 1" descr="icon_x.png">    </p:cNvPr>
+          <p:cNvPr id="9" name="Image 1" descr="icon_x.png">    </p:cNvPr>
           <p:cNvPicPr>
             <a:picLocks noChangeAspect="1"/>
           </p:cNvPicPr>
@@ -2327,7 +2444,7 @@
       </p:pic>
       <p:sp>
         <p:nvSpPr>
-          <p:cNvPr id="9" name="Text 5"/>
+          <p:cNvPr id="10" name="Text 6"/>
           <p:cNvSpPr/>
           <p:nvPr/>
         </p:nvSpPr>
@@ -2352,7 +2469,7 @@
             <a:r>
               <a:rPr lang="en-US" sz="1450" dirty="0">
                 <a:solidFill>
-                  <a:srgbClr val="13343B"/>
+                  <a:srgbClr val="1A1A1A"/>
                 </a:solidFill>
                 <a:latin typeface="Calibri" pitchFamily="34" charset="0"/>
                 <a:ea typeface="Calibri" pitchFamily="34" charset="-122"/>
@@ -2366,7 +2483,7 @@
       </p:sp>
       <p:pic>
         <p:nvPicPr>
-          <p:cNvPr id="10" name="Image 2" descr="icon_x.png">    </p:cNvPr>
+          <p:cNvPr id="11" name="Image 2" descr="icon_x.png">    </p:cNvPr>
           <p:cNvPicPr>
             <a:picLocks noChangeAspect="1"/>
           </p:cNvPicPr>
@@ -2390,7 +2507,7 @@
       </p:pic>
       <p:sp>
         <p:nvSpPr>
-          <p:cNvPr id="11" name="Text 6"/>
+          <p:cNvPr id="12" name="Text 7"/>
           <p:cNvSpPr/>
           <p:nvPr/>
         </p:nvSpPr>
@@ -2415,7 +2532,7 @@
             <a:r>
               <a:rPr lang="en-US" sz="1450" dirty="0">
                 <a:solidFill>
-                  <a:srgbClr val="13343B"/>
+                  <a:srgbClr val="1A1A1A"/>
                 </a:solidFill>
                 <a:latin typeface="Calibri" pitchFamily="34" charset="0"/>
                 <a:ea typeface="Calibri" pitchFamily="34" charset="-122"/>
@@ -2429,7 +2546,7 @@
       </p:sp>
       <p:sp>
         <p:nvSpPr>
-          <p:cNvPr id="12" name="Shape 7"/>
+          <p:cNvPr id="13" name="Shape 8"/>
           <p:cNvSpPr/>
           <p:nvPr/>
         </p:nvSpPr>
@@ -2444,14 +2561,14 @@
             </a:avLst>
           </a:prstGeom>
           <a:solidFill>
-            <a:srgbClr val="E6F4F1"/>
+            <a:srgbClr val="E8EEEA"/>
           </a:solidFill>
           <a:ln/>
         </p:spPr>
       </p:sp>
       <p:sp>
         <p:nvSpPr>
-          <p:cNvPr id="13" name="Text 8"/>
+          <p:cNvPr id="14" name="Text 9"/>
           <p:cNvSpPr/>
           <p:nvPr/>
         </p:nvSpPr>
@@ -2476,7 +2593,7 @@
             <a:r>
               <a:rPr lang="en-US" sz="1800" b="1" dirty="0">
                 <a:solidFill>
-                  <a:srgbClr val="028090"/>
+                  <a:srgbClr val="1C4A34"/>
                 </a:solidFill>
                 <a:latin typeface="Calibri" pitchFamily="34" charset="0"/>
                 <a:ea typeface="Calibri" pitchFamily="34" charset="-122"/>
@@ -2490,7 +2607,7 @@
       </p:sp>
       <p:pic>
         <p:nvPicPr>
-          <p:cNvPr id="14" name="Image 3" descr="icon_check.png">    </p:cNvPr>
+          <p:cNvPr id="15" name="Image 3" descr="icon_check.png">    </p:cNvPr>
           <p:cNvPicPr>
             <a:picLocks noChangeAspect="1"/>
           </p:cNvPicPr>
@@ -2514,7 +2631,7 @@
       </p:pic>
       <p:sp>
         <p:nvSpPr>
-          <p:cNvPr id="15" name="Text 9"/>
+          <p:cNvPr id="16" name="Text 10"/>
           <p:cNvSpPr/>
           <p:nvPr/>
         </p:nvSpPr>
@@ -2539,7 +2656,7 @@
             <a:r>
               <a:rPr lang="en-US" sz="1450" dirty="0">
                 <a:solidFill>
-                  <a:srgbClr val="13343B"/>
+                  <a:srgbClr val="1A1A1A"/>
                 </a:solidFill>
                 <a:latin typeface="Calibri" pitchFamily="34" charset="0"/>
                 <a:ea typeface="Calibri" pitchFamily="34" charset="-122"/>
@@ -2553,7 +2670,7 @@
       </p:sp>
       <p:pic>
         <p:nvPicPr>
-          <p:cNvPr id="16" name="Image 4" descr="icon_check.png">    </p:cNvPr>
+          <p:cNvPr id="17" name="Image 4" descr="icon_check.png">    </p:cNvPr>
           <p:cNvPicPr>
             <a:picLocks noChangeAspect="1"/>
           </p:cNvPicPr>
@@ -2577,7 +2694,7 @@
       </p:pic>
       <p:sp>
         <p:nvSpPr>
-          <p:cNvPr id="17" name="Text 10"/>
+          <p:cNvPr id="18" name="Text 11"/>
           <p:cNvSpPr/>
           <p:nvPr/>
         </p:nvSpPr>
@@ -2602,7 +2719,7 @@
             <a:r>
               <a:rPr lang="en-US" sz="1450" dirty="0">
                 <a:solidFill>
-                  <a:srgbClr val="13343B"/>
+                  <a:srgbClr val="1A1A1A"/>
                 </a:solidFill>
                 <a:latin typeface="Calibri" pitchFamily="34" charset="0"/>
                 <a:ea typeface="Calibri" pitchFamily="34" charset="-122"/>
@@ -2616,7 +2733,7 @@
       </p:sp>
       <p:pic>
         <p:nvPicPr>
-          <p:cNvPr id="18" name="Image 5" descr="icon_check.png">    </p:cNvPr>
+          <p:cNvPr id="19" name="Image 5" descr="icon_check.png">    </p:cNvPr>
           <p:cNvPicPr>
             <a:picLocks noChangeAspect="1"/>
           </p:cNvPicPr>
@@ -2640,7 +2757,7 @@
       </p:pic>
       <p:sp>
         <p:nvSpPr>
-          <p:cNvPr id="19" name="Text 11"/>
+          <p:cNvPr id="20" name="Text 12"/>
           <p:cNvSpPr/>
           <p:nvPr/>
         </p:nvSpPr>
@@ -2665,7 +2782,7 @@
             <a:r>
               <a:rPr lang="en-US" sz="1450" dirty="0">
                 <a:solidFill>
-                  <a:srgbClr val="13343B"/>
+                  <a:srgbClr val="1A1A1A"/>
                 </a:solidFill>
                 <a:latin typeface="Calibri" pitchFamily="34" charset="0"/>
                 <a:ea typeface="Calibri" pitchFamily="34" charset="-122"/>
@@ -2679,7 +2796,7 @@
       </p:sp>
       <p:sp>
         <p:nvSpPr>
-          <p:cNvPr id="20" name="Text 12"/>
+          <p:cNvPr id="21" name="Text 13"/>
           <p:cNvSpPr/>
           <p:nvPr/>
         </p:nvSpPr>
@@ -2704,7 +2821,7 @@
             <a:r>
               <a:rPr lang="en-US" sz="1900" b="1" i="1" dirty="0">
                 <a:solidFill>
-                  <a:srgbClr val="13343B"/>
+                  <a:srgbClr val="1A1A1A"/>
                 </a:solidFill>
                 <a:latin typeface="Cambria" pitchFamily="34" charset="0"/>
                 <a:ea typeface="Cambria" pitchFamily="34" charset="-122"/>

</xml_diff>